<commit_message>
Week 4: update to Tableau, rewrite in plainer voice, recolor slides
</commit_message>
<xml_diff>
--- a/week-04-mini-project-review/slides/week-04-slides.pptx
+++ b/week-04-mini-project-review/slides/week-04-slides.pptx
@@ -11,10 +11,9 @@
     <p:sldId id="259" r:id="rId5"/>
     <p:sldId id="260" r:id="rId6"/>
     <p:sldId id="261" r:id="rId7"/>
-    <p:sldId id="262" r:id="rId8"/>
   </p:sldIdLst>
   <p:notesMasterIdLst>
-    <p:notesMasterId r:id="rId9"/>
+    <p:notesMasterId r:id="rId8"/>
   </p:notesMasterIdLst>
   <p:sldSz cx="12192000" cy="6858000"/>
   <p:notesSz cx="6858000" cy="12192000"/>
@@ -972,94 +971,6 @@
             <a:fld id="{F7021451-1387-4CA6-816F-3879F97B5CBC}" type="slidenum">
               <a:rPr lang="en-US"/>
               <a:t>6</a:t>
-            </a:fld>
-            <a:endParaRPr lang="en-US"/>
-          </a:p>
-        </p:txBody>
-      </p:sp>
-    </p:spTree>
-    <p:extLst>
-      <p:ext uri="{BB962C8B-B14F-4D97-AF65-F5344CB8AC3E}">
-        <p14:creationId xmlns:p14="http://schemas.microsoft.com/office/powerpoint/2010/main" val="1024086991"/>
-      </p:ext>
-    </p:extLst>
-  </p:cSld>
-  <p:clrMapOvr>
-    <a:masterClrMapping/>
-  </p:clrMapOvr>
-</p:notes>
-</file>
-
-<file path=ppt/notesSlides/notesSlide7.xml><?xml version="1.0" encoding="utf-8"?>
-<p:notes xmlns:a="http://schemas.openxmlformats.org/drawingml/2006/main" xmlns:r="http://schemas.openxmlformats.org/officeDocument/2006/relationships" xmlns:p="http://schemas.openxmlformats.org/presentationml/2006/main">
-  <p:cSld>
-    <p:spTree>
-      <p:nvGrpSpPr>
-        <p:cNvPr id="1" name=""/>
-        <p:cNvGrpSpPr/>
-        <p:nvPr/>
-      </p:nvGrpSpPr>
-      <p:grpSpPr>
-        <a:xfrm>
-          <a:off x="0" y="0"/>
-          <a:ext cx="0" cy="0"/>
-          <a:chOff x="0" y="0"/>
-          <a:chExt cx="0" cy="0"/>
-        </a:xfrm>
-      </p:grpSpPr>
-      <p:sp>
-        <p:nvSpPr>
-          <p:cNvPr id="2" name="Slide Image Placeholder 1"/>
-          <p:cNvSpPr>
-            <a:spLocks noGrp="1" noRot="1" noChangeAspect="1"/>
-          </p:cNvSpPr>
-          <p:nvPr>
-            <p:ph type="sldImg"/>
-          </p:nvPr>
-        </p:nvSpPr>
-        <p:spPr/>
-      </p:sp>
-      <p:sp>
-        <p:nvSpPr>
-          <p:cNvPr id="3" name="Notes Placeholder 2"/>
-          <p:cNvSpPr>
-            <a:spLocks noGrp="1"/>
-          </p:cNvSpPr>
-          <p:nvPr>
-            <p:ph type="body" idx="1"/>
-          </p:nvPr>
-        </p:nvSpPr>
-        <p:spPr/>
-        <p:txBody>
-          <a:bodyPr/>
-          <a:lstStyle/>
-          <a:p>
-            <a:r>
-              <a:rPr lang="en-US" dirty="0"/>
-              <a:t/>
-            </a:r>
-            <a:endParaRPr lang="en-US" dirty="0"/>
-          </a:p>
-        </p:txBody>
-      </p:sp>
-      <p:sp>
-        <p:nvSpPr>
-          <p:cNvPr id="4" name="Slide Number Placeholder 3"/>
-          <p:cNvSpPr>
-            <a:spLocks noGrp="1"/>
-          </p:cNvSpPr>
-          <p:nvPr>
-            <p:ph type="sldNum" sz="quarter" idx="10"/>
-          </p:nvPr>
-        </p:nvSpPr>
-        <p:spPr/>
-        <p:txBody>
-          <a:bodyPr/>
-          <a:lstStyle/>
-          <a:p>
-            <a:fld id="{F7021451-1387-4CA6-816F-3879F97B5CBC}" type="slidenum">
-              <a:rPr lang="en-US"/>
-              <a:t>7</a:t>
             </a:fld>
             <a:endParaRPr lang="en-US"/>
           </a:p>
@@ -1391,7 +1302,7 @@
     <p:bg>
       <p:bgPr>
         <a:solidFill>
-          <a:srgbClr val="1B3A34"/>
+          <a:srgbClr val="1C3F60"/>
         </a:solidFill>
       </p:bgPr>
     </p:bg>
@@ -1442,7 +1353,7 @@
                 <a:ea typeface="Calibri" pitchFamily="34" charset="-122"/>
                 <a:cs typeface="Calibri" pitchFamily="34" charset="-120"/>
               </a:rPr>
-              <a:t>DATA ANALYTICS BRANCH</a:t>
+              <a:t>DATA ANALYTICS BRANCH · WEEK 4</a:t>
             </a:r>
             <a:endParaRPr lang="en-US" sz="1300" dirty="0"/>
           </a:p>
@@ -1456,7 +1367,7 @@
         </p:nvSpPr>
         <p:spPr>
           <a:xfrm>
-            <a:off x="640080" y="2377440"/>
+            <a:off x="640080" y="2286000"/>
             <a:ext cx="10515600" cy="1645920"/>
           </a:xfrm>
           <a:prstGeom prst="rect">
@@ -1512,8 +1423,8 @@
         </p:nvSpPr>
         <p:spPr>
           <a:xfrm>
-            <a:off x="640080" y="3794760"/>
-            <a:ext cx="10058400" cy="731520"/>
+            <a:off x="640080" y="3703320"/>
+            <a:ext cx="10058400" cy="822960"/>
           </a:xfrm>
           <a:prstGeom prst="rect">
             <a:avLst/>
@@ -1529,17 +1440,17 @@
               <a:buNone/>
             </a:pPr>
             <a:r>
-              <a:rPr lang="en-US" sz="1800" dirty="0">
-                <a:solidFill>
-                  <a:srgbClr val="D8E4E0"/>
+              <a:rPr lang="en-US" sz="1700" dirty="0">
+                <a:solidFill>
+                  <a:srgbClr val="D6E2EA"/>
                 </a:solidFill>
                 <a:latin typeface="Calibri" pitchFamily="34" charset="0"/>
                 <a:ea typeface="Calibri" pitchFamily="34" charset="-122"/>
                 <a:cs typeface="Calibri" pitchFamily="34" charset="-120"/>
               </a:rPr>
-              <a:t>DSDG Data Analytics — Week 4 · Cycle 1 Review</a:t>
-            </a:r>
-            <a:endParaRPr lang="en-US" sz="1800" dirty="0"/>
+              <a:t>No new content today — Weeks 2 and 3, without a script.</a:t>
+            </a:r>
+            <a:endParaRPr lang="en-US" sz="1700" dirty="0"/>
           </a:p>
         </p:txBody>
       </p:sp>
@@ -1551,7 +1462,7 @@
         </p:nvSpPr>
         <p:spPr>
           <a:xfrm>
-            <a:off x="640080" y="2148840"/>
+            <a:off x="640080" y="2057400"/>
             <a:ext cx="1280160" cy="45720"/>
           </a:xfrm>
           <a:prstGeom prst="rect">
@@ -1628,7 +1539,7 @@
                 <a:ea typeface="Calibri" pitchFamily="34" charset="-122"/>
                 <a:cs typeface="Calibri" pitchFamily="34" charset="-120"/>
               </a:rPr>
-              <a:t>TODAY</a:t>
+              <a:t>COMING IN</a:t>
             </a:r>
             <a:endParaRPr lang="en-US" sz="1200" dirty="0"/>
           </a:p>
@@ -1661,13 +1572,13 @@
             <a:r>
               <a:rPr lang="en-US" sz="2700" b="1" dirty="0">
                 <a:solidFill>
-                  <a:srgbClr val="1B3A34"/>
+                  <a:srgbClr val="1C3F60"/>
                 </a:solidFill>
                 <a:latin typeface="Georgia" pitchFamily="34" charset="0"/>
                 <a:ea typeface="Georgia" pitchFamily="34" charset="-122"/>
                 <a:cs typeface="Georgia" pitchFamily="34" charset="-120"/>
               </a:rPr>
-              <a:t>No new content — this is the payoff</a:t>
+              <a:t>The four requirements</a:t>
             </a:r>
             <a:endParaRPr lang="en-US" sz="2700" dirty="0"/>
           </a:p>
@@ -1675,14 +1586,34 @@
       </p:sp>
       <p:sp>
         <p:nvSpPr>
-          <p:cNvPr id="4" name="Text 2"/>
-          <p:cNvSpPr/>
-          <p:nvPr/>
-        </p:nvSpPr>
-        <p:spPr>
-          <a:xfrm>
-            <a:off x="640080" y="2103120"/>
-            <a:ext cx="10058400" cy="914400"/>
+          <p:cNvPr id="4" name="Shape 2"/>
+          <p:cNvSpPr/>
+          <p:nvPr/>
+        </p:nvSpPr>
+        <p:spPr>
+          <a:xfrm>
+            <a:off x="640080" y="1965960"/>
+            <a:ext cx="2514600" cy="3108960"/>
+          </a:xfrm>
+          <a:prstGeom prst="rect">
+            <a:avLst/>
+          </a:prstGeom>
+          <a:solidFill>
+            <a:srgbClr val="F4F1EC"/>
+          </a:solidFill>
+          <a:ln/>
+        </p:spPr>
+      </p:sp>
+      <p:sp>
+        <p:nvSpPr>
+          <p:cNvPr id="5" name="Text 3"/>
+          <p:cNvSpPr/>
+          <p:nvPr/>
+        </p:nvSpPr>
+        <p:spPr>
+          <a:xfrm>
+            <a:off x="868680" y="2194560"/>
+            <a:ext cx="2057400" cy="548640"/>
           </a:xfrm>
           <a:prstGeom prst="rect">
             <a:avLst/>
@@ -1700,13 +1631,13 @@
             <a:r>
               <a:rPr lang="en-US" sz="2400" b="1" dirty="0">
                 <a:solidFill>
-                  <a:srgbClr val="1B3A34"/>
+                  <a:srgbClr val="D97E3F"/>
                 </a:solidFill>
                 <a:latin typeface="Georgia" pitchFamily="34" charset="0"/>
                 <a:ea typeface="Georgia" pitchFamily="34" charset="-122"/>
                 <a:cs typeface="Georgia" pitchFamily="34" charset="-120"/>
               </a:rPr>
-              <a:t>Everything from Weeks 2 and 3, now without a script.</a:t>
+              <a:t>1</a:t>
             </a:r>
             <a:endParaRPr lang="en-US" sz="2400" dirty="0"/>
           </a:p>
@@ -1714,69 +1645,69 @@
       </p:sp>
       <p:sp>
         <p:nvSpPr>
-          <p:cNvPr id="5" name="Text 3"/>
-          <p:cNvSpPr/>
-          <p:nvPr/>
-        </p:nvSpPr>
-        <p:spPr>
-          <a:xfrm>
-            <a:off x="640080" y="3291840"/>
-            <a:ext cx="9875520" cy="457200"/>
-          </a:xfrm>
-          <a:prstGeom prst="rect">
-            <a:avLst/>
-          </a:prstGeom>
-          <a:noFill/>
-          <a:ln/>
-        </p:spPr>
-        <p:txBody>
-          <a:bodyPr wrap="square" rtlCol="0" anchor="ctr"/>
-          <a:lstStyle/>
-          <a:p>
-            <a:pPr indent="0" marL="0">
-              <a:buNone/>
-            </a:pPr>
-            <a:r>
-              <a:rPr lang="en-US" sz="1700" dirty="0">
-                <a:solidFill>
-                  <a:srgbClr val="2A2A2A"/>
+          <p:cNvPr id="6" name="Text 4"/>
+          <p:cNvSpPr/>
+          <p:nvPr/>
+        </p:nvSpPr>
+        <p:spPr>
+          <a:xfrm>
+            <a:off x="868680" y="2743200"/>
+            <a:ext cx="2057400" cy="731520"/>
+          </a:xfrm>
+          <a:prstGeom prst="rect">
+            <a:avLst/>
+          </a:prstGeom>
+          <a:noFill/>
+          <a:ln/>
+        </p:spPr>
+        <p:txBody>
+          <a:bodyPr wrap="square" rtlCol="0" anchor="t"/>
+          <a:lstStyle/>
+          <a:p>
+            <a:pPr indent="0" marL="0">
+              <a:buNone/>
+            </a:pPr>
+            <a:r>
+              <a:rPr lang="en-US" sz="1500" b="1" dirty="0">
+                <a:solidFill>
+                  <a:srgbClr val="1C3F60"/>
                 </a:solidFill>
                 <a:latin typeface="Calibri" pitchFamily="34" charset="0"/>
                 <a:ea typeface="Calibri" pitchFamily="34" charset="-122"/>
                 <a:cs typeface="Calibri" pitchFamily="34" charset="-120"/>
               </a:rPr>
-              <a:t>•  Your own question</a:t>
-            </a:r>
-            <a:endParaRPr lang="en-US" sz="1700" dirty="0"/>
-          </a:p>
-        </p:txBody>
-      </p:sp>
-      <p:sp>
-        <p:nvSpPr>
-          <p:cNvPr id="6" name="Text 4"/>
-          <p:cNvSpPr/>
-          <p:nvPr/>
-        </p:nvSpPr>
-        <p:spPr>
-          <a:xfrm>
-            <a:off x="640080" y="3794760"/>
-            <a:ext cx="9875520" cy="457200"/>
-          </a:xfrm>
-          <a:prstGeom prst="rect">
-            <a:avLst/>
-          </a:prstGeom>
-          <a:noFill/>
-          <a:ln/>
-        </p:spPr>
-        <p:txBody>
-          <a:bodyPr wrap="square" rtlCol="0" anchor="ctr"/>
-          <a:lstStyle/>
-          <a:p>
-            <a:pPr indent="0" marL="0">
-              <a:buNone/>
-            </a:pPr>
-            <a:r>
-              <a:rPr lang="en-US" sz="1700" dirty="0">
+              <a:t>A clear claim</a:t>
+            </a:r>
+            <a:endParaRPr lang="en-US" sz="1500" dirty="0"/>
+          </a:p>
+        </p:txBody>
+      </p:sp>
+      <p:sp>
+        <p:nvSpPr>
+          <p:cNvPr id="7" name="Text 5"/>
+          <p:cNvSpPr/>
+          <p:nvPr/>
+        </p:nvSpPr>
+        <p:spPr>
+          <a:xfrm>
+            <a:off x="868680" y="3429000"/>
+            <a:ext cx="2057400" cy="1463040"/>
+          </a:xfrm>
+          <a:prstGeom prst="rect">
+            <a:avLst/>
+          </a:prstGeom>
+          <a:noFill/>
+          <a:ln/>
+        </p:spPr>
+        <p:txBody>
+          <a:bodyPr wrap="square" rtlCol="0" anchor="t"/>
+          <a:lstStyle/>
+          <a:p>
+            <a:pPr indent="0" marL="0">
+              <a:buNone/>
+            </a:pPr>
+            <a:r>
+              <a:rPr lang="en-US" sz="1200" dirty="0">
                 <a:solidFill>
                   <a:srgbClr val="2A2A2A"/>
                 </a:solidFill>
@@ -1784,22 +1715,42 @@
                 <a:ea typeface="Calibri" pitchFamily="34" charset="-122"/>
                 <a:cs typeface="Calibri" pitchFamily="34" charset="-120"/>
               </a:rPr>
-              <a:t>•  Your own engineered column</a:t>
-            </a:r>
-            <a:endParaRPr lang="en-US" sz="1700" dirty="0"/>
-          </a:p>
-        </p:txBody>
-      </p:sp>
-      <p:sp>
-        <p:nvSpPr>
-          <p:cNvPr id="7" name="Text 5"/>
-          <p:cNvSpPr/>
-          <p:nvPr/>
-        </p:nvSpPr>
-        <p:spPr>
-          <a:xfrm>
-            <a:off x="640080" y="4297680"/>
-            <a:ext cx="9875520" cy="457200"/>
+              <a:t>a sentence, not just a chart</a:t>
+            </a:r>
+            <a:endParaRPr lang="en-US" sz="1200" dirty="0"/>
+          </a:p>
+        </p:txBody>
+      </p:sp>
+      <p:sp>
+        <p:nvSpPr>
+          <p:cNvPr id="8" name="Shape 6"/>
+          <p:cNvSpPr/>
+          <p:nvPr/>
+        </p:nvSpPr>
+        <p:spPr>
+          <a:xfrm>
+            <a:off x="3337560" y="1965960"/>
+            <a:ext cx="2514600" cy="3108960"/>
+          </a:xfrm>
+          <a:prstGeom prst="rect">
+            <a:avLst/>
+          </a:prstGeom>
+          <a:solidFill>
+            <a:srgbClr val="F4F1EC"/>
+          </a:solidFill>
+          <a:ln/>
+        </p:spPr>
+      </p:sp>
+      <p:sp>
+        <p:nvSpPr>
+          <p:cNvPr id="9" name="Text 7"/>
+          <p:cNvSpPr/>
+          <p:nvPr/>
+        </p:nvSpPr>
+        <p:spPr>
+          <a:xfrm>
+            <a:off x="3566160" y="2194560"/>
+            <a:ext cx="2057400" cy="548640"/>
           </a:xfrm>
           <a:prstGeom prst="rect">
             <a:avLst/>
@@ -1815,17 +1766,369 @@
               <a:buNone/>
             </a:pPr>
             <a:r>
-              <a:rPr lang="en-US" sz="1700" dirty="0">
-                <a:solidFill>
-                  <a:srgbClr val="2A2A2A"/>
+              <a:rPr lang="en-US" sz="2400" b="1" dirty="0">
+                <a:solidFill>
+                  <a:srgbClr val="D97E3F"/>
+                </a:solidFill>
+                <a:latin typeface="Georgia" pitchFamily="34" charset="0"/>
+                <a:ea typeface="Georgia" pitchFamily="34" charset="-122"/>
+                <a:cs typeface="Georgia" pitchFamily="34" charset="-120"/>
+              </a:rPr>
+              <a:t>2</a:t>
+            </a:r>
+            <a:endParaRPr lang="en-US" sz="2400" dirty="0"/>
+          </a:p>
+        </p:txBody>
+      </p:sp>
+      <p:sp>
+        <p:nvSpPr>
+          <p:cNvPr id="10" name="Text 8"/>
+          <p:cNvSpPr/>
+          <p:nvPr/>
+        </p:nvSpPr>
+        <p:spPr>
+          <a:xfrm>
+            <a:off x="3566160" y="2743200"/>
+            <a:ext cx="2057400" cy="731520"/>
+          </a:xfrm>
+          <a:prstGeom prst="rect">
+            <a:avLst/>
+          </a:prstGeom>
+          <a:noFill/>
+          <a:ln/>
+        </p:spPr>
+        <p:txBody>
+          <a:bodyPr wrap="square" rtlCol="0" anchor="t"/>
+          <a:lstStyle/>
+          <a:p>
+            <a:pPr indent="0" marL="0">
+              <a:buNone/>
+            </a:pPr>
+            <a:r>
+              <a:rPr lang="en-US" sz="1500" b="1" dirty="0">
+                <a:solidFill>
+                  <a:srgbClr val="1C3F60"/>
                 </a:solidFill>
                 <a:latin typeface="Calibri" pitchFamily="34" charset="0"/>
                 <a:ea typeface="Calibri" pitchFamily="34" charset="-122"/>
                 <a:cs typeface="Calibri" pitchFamily="34" charset="-120"/>
               </a:rPr>
-              <a:t>•  Your own Excel analysis + Power BI dashboard</a:t>
-            </a:r>
-            <a:endParaRPr lang="en-US" sz="1700" dirty="0"/>
+              <a:t>An engineered column</a:t>
+            </a:r>
+            <a:endParaRPr lang="en-US" sz="1500" dirty="0"/>
+          </a:p>
+        </p:txBody>
+      </p:sp>
+      <p:sp>
+        <p:nvSpPr>
+          <p:cNvPr id="11" name="Text 9"/>
+          <p:cNvSpPr/>
+          <p:nvPr/>
+        </p:nvSpPr>
+        <p:spPr>
+          <a:xfrm>
+            <a:off x="3566160" y="3429000"/>
+            <a:ext cx="2057400" cy="1463040"/>
+          </a:xfrm>
+          <a:prstGeom prst="rect">
+            <a:avLst/>
+          </a:prstGeom>
+          <a:noFill/>
+          <a:ln/>
+        </p:spPr>
+        <p:txBody>
+          <a:bodyPr wrap="square" rtlCol="0" anchor="t"/>
+          <a:lstStyle/>
+          <a:p>
+            <a:pPr indent="0" marL="0">
+              <a:buNone/>
+            </a:pPr>
+            <a:r>
+              <a:rPr lang="en-US" sz="1200" dirty="0">
+                <a:solidFill>
+                  <a:srgbClr val="2A2A2A"/>
+                </a:solidFill>
+                <a:latin typeface="Calibri" pitchFamily="34" charset="0"/>
+                <a:ea typeface="Calibri" pitchFamily="34" charset="-122"/>
+                <a:cs typeface="Calibri" pitchFamily="34" charset="-120"/>
+              </a:rPr>
+              <a:t>computed, not raw</a:t>
+            </a:r>
+            <a:endParaRPr lang="en-US" sz="1200" dirty="0"/>
+          </a:p>
+        </p:txBody>
+      </p:sp>
+      <p:sp>
+        <p:nvSpPr>
+          <p:cNvPr id="12" name="Shape 10"/>
+          <p:cNvSpPr/>
+          <p:nvPr/>
+        </p:nvSpPr>
+        <p:spPr>
+          <a:xfrm>
+            <a:off x="6035040" y="1965960"/>
+            <a:ext cx="2514600" cy="3108960"/>
+          </a:xfrm>
+          <a:prstGeom prst="rect">
+            <a:avLst/>
+          </a:prstGeom>
+          <a:solidFill>
+            <a:srgbClr val="F4F1EC"/>
+          </a:solidFill>
+          <a:ln/>
+        </p:spPr>
+      </p:sp>
+      <p:sp>
+        <p:nvSpPr>
+          <p:cNvPr id="13" name="Text 11"/>
+          <p:cNvSpPr/>
+          <p:nvPr/>
+        </p:nvSpPr>
+        <p:spPr>
+          <a:xfrm>
+            <a:off x="6263640" y="2194560"/>
+            <a:ext cx="2057400" cy="548640"/>
+          </a:xfrm>
+          <a:prstGeom prst="rect">
+            <a:avLst/>
+          </a:prstGeom>
+          <a:noFill/>
+          <a:ln/>
+        </p:spPr>
+        <p:txBody>
+          <a:bodyPr wrap="square" rtlCol="0" anchor="ctr"/>
+          <a:lstStyle/>
+          <a:p>
+            <a:pPr indent="0" marL="0">
+              <a:buNone/>
+            </a:pPr>
+            <a:r>
+              <a:rPr lang="en-US" sz="2400" b="1" dirty="0">
+                <a:solidFill>
+                  <a:srgbClr val="D97E3F"/>
+                </a:solidFill>
+                <a:latin typeface="Georgia" pitchFamily="34" charset="0"/>
+                <a:ea typeface="Georgia" pitchFamily="34" charset="-122"/>
+                <a:cs typeface="Georgia" pitchFamily="34" charset="-120"/>
+              </a:rPr>
+              <a:t>3</a:t>
+            </a:r>
+            <a:endParaRPr lang="en-US" sz="2400" dirty="0"/>
+          </a:p>
+        </p:txBody>
+      </p:sp>
+      <p:sp>
+        <p:nvSpPr>
+          <p:cNvPr id="14" name="Text 12"/>
+          <p:cNvSpPr/>
+          <p:nvPr/>
+        </p:nvSpPr>
+        <p:spPr>
+          <a:xfrm>
+            <a:off x="6263640" y="2743200"/>
+            <a:ext cx="2057400" cy="731520"/>
+          </a:xfrm>
+          <a:prstGeom prst="rect">
+            <a:avLst/>
+          </a:prstGeom>
+          <a:noFill/>
+          <a:ln/>
+        </p:spPr>
+        <p:txBody>
+          <a:bodyPr wrap="square" rtlCol="0" anchor="t"/>
+          <a:lstStyle/>
+          <a:p>
+            <a:pPr indent="0" marL="0">
+              <a:buNone/>
+            </a:pPr>
+            <a:r>
+              <a:rPr lang="en-US" sz="1500" b="1" dirty="0">
+                <a:solidFill>
+                  <a:srgbClr val="1C3F60"/>
+                </a:solidFill>
+                <a:latin typeface="Calibri" pitchFamily="34" charset="0"/>
+                <a:ea typeface="Calibri" pitchFamily="34" charset="-122"/>
+                <a:cs typeface="Calibri" pitchFamily="34" charset="-120"/>
+              </a:rPr>
+              <a:t>Excel + Tableau</a:t>
+            </a:r>
+            <a:endParaRPr lang="en-US" sz="1500" dirty="0"/>
+          </a:p>
+        </p:txBody>
+      </p:sp>
+      <p:sp>
+        <p:nvSpPr>
+          <p:cNvPr id="15" name="Text 13"/>
+          <p:cNvSpPr/>
+          <p:nvPr/>
+        </p:nvSpPr>
+        <p:spPr>
+          <a:xfrm>
+            <a:off x="6263640" y="3429000"/>
+            <a:ext cx="2057400" cy="1463040"/>
+          </a:xfrm>
+          <a:prstGeom prst="rect">
+            <a:avLst/>
+          </a:prstGeom>
+          <a:noFill/>
+          <a:ln/>
+        </p:spPr>
+        <p:txBody>
+          <a:bodyPr wrap="square" rtlCol="0" anchor="t"/>
+          <a:lstStyle/>
+          <a:p>
+            <a:pPr indent="0" marL="0">
+              <a:buNone/>
+            </a:pPr>
+            <a:r>
+              <a:rPr lang="en-US" sz="1200" dirty="0">
+                <a:solidFill>
+                  <a:srgbClr val="2A2A2A"/>
+                </a:solidFill>
+                <a:latin typeface="Calibri" pitchFamily="34" charset="0"/>
+                <a:ea typeface="Calibri" pitchFamily="34" charset="-122"/>
+                <a:cs typeface="Calibri" pitchFamily="34" charset="-120"/>
+              </a:rPr>
+              <a:t>both, together</a:t>
+            </a:r>
+            <a:endParaRPr lang="en-US" sz="1200" dirty="0"/>
+          </a:p>
+        </p:txBody>
+      </p:sp>
+      <p:sp>
+        <p:nvSpPr>
+          <p:cNvPr id="16" name="Shape 14"/>
+          <p:cNvSpPr/>
+          <p:nvPr/>
+        </p:nvSpPr>
+        <p:spPr>
+          <a:xfrm>
+            <a:off x="8732520" y="1965960"/>
+            <a:ext cx="2514600" cy="3108960"/>
+          </a:xfrm>
+          <a:prstGeom prst="rect">
+            <a:avLst/>
+          </a:prstGeom>
+          <a:solidFill>
+            <a:srgbClr val="F4F1EC"/>
+          </a:solidFill>
+          <a:ln/>
+        </p:spPr>
+      </p:sp>
+      <p:sp>
+        <p:nvSpPr>
+          <p:cNvPr id="17" name="Text 15"/>
+          <p:cNvSpPr/>
+          <p:nvPr/>
+        </p:nvSpPr>
+        <p:spPr>
+          <a:xfrm>
+            <a:off x="8961120" y="2194560"/>
+            <a:ext cx="2057400" cy="548640"/>
+          </a:xfrm>
+          <a:prstGeom prst="rect">
+            <a:avLst/>
+          </a:prstGeom>
+          <a:noFill/>
+          <a:ln/>
+        </p:spPr>
+        <p:txBody>
+          <a:bodyPr wrap="square" rtlCol="0" anchor="ctr"/>
+          <a:lstStyle/>
+          <a:p>
+            <a:pPr indent="0" marL="0">
+              <a:buNone/>
+            </a:pPr>
+            <a:r>
+              <a:rPr lang="en-US" sz="2400" b="1" dirty="0">
+                <a:solidFill>
+                  <a:srgbClr val="D97E3F"/>
+                </a:solidFill>
+                <a:latin typeface="Georgia" pitchFamily="34" charset="0"/>
+                <a:ea typeface="Georgia" pitchFamily="34" charset="-122"/>
+                <a:cs typeface="Georgia" pitchFamily="34" charset="-120"/>
+              </a:rPr>
+              <a:t>4</a:t>
+            </a:r>
+            <a:endParaRPr lang="en-US" sz="2400" dirty="0"/>
+          </a:p>
+        </p:txBody>
+      </p:sp>
+      <p:sp>
+        <p:nvSpPr>
+          <p:cNvPr id="18" name="Text 16"/>
+          <p:cNvSpPr/>
+          <p:nvPr/>
+        </p:nvSpPr>
+        <p:spPr>
+          <a:xfrm>
+            <a:off x="8961120" y="2743200"/>
+            <a:ext cx="2057400" cy="731520"/>
+          </a:xfrm>
+          <a:prstGeom prst="rect">
+            <a:avLst/>
+          </a:prstGeom>
+          <a:noFill/>
+          <a:ln/>
+        </p:spPr>
+        <p:txBody>
+          <a:bodyPr wrap="square" rtlCol="0" anchor="t"/>
+          <a:lstStyle/>
+          <a:p>
+            <a:pPr indent="0" marL="0">
+              <a:buNone/>
+            </a:pPr>
+            <a:r>
+              <a:rPr lang="en-US" sz="1500" b="1" dirty="0">
+                <a:solidFill>
+                  <a:srgbClr val="1C3F60"/>
+                </a:solidFill>
+                <a:latin typeface="Calibri" pitchFamily="34" charset="0"/>
+                <a:ea typeface="Calibri" pitchFamily="34" charset="-122"/>
+                <a:cs typeface="Calibri" pitchFamily="34" charset="-120"/>
+              </a:rPr>
+              <a:t>A named limitation</a:t>
+            </a:r>
+            <a:endParaRPr lang="en-US" sz="1500" dirty="0"/>
+          </a:p>
+        </p:txBody>
+      </p:sp>
+      <p:sp>
+        <p:nvSpPr>
+          <p:cNvPr id="19" name="Text 17"/>
+          <p:cNvSpPr/>
+          <p:nvPr/>
+        </p:nvSpPr>
+        <p:spPr>
+          <a:xfrm>
+            <a:off x="8961120" y="3429000"/>
+            <a:ext cx="2057400" cy="1463040"/>
+          </a:xfrm>
+          <a:prstGeom prst="rect">
+            <a:avLst/>
+          </a:prstGeom>
+          <a:noFill/>
+          <a:ln/>
+        </p:spPr>
+        <p:txBody>
+          <a:bodyPr wrap="square" rtlCol="0" anchor="t"/>
+          <a:lstStyle/>
+          <a:p>
+            <a:pPr indent="0" marL="0">
+              <a:buNone/>
+            </a:pPr>
+            <a:r>
+              <a:rPr lang="en-US" sz="1200" dirty="0">
+                <a:solidFill>
+                  <a:srgbClr val="2A2A2A"/>
+                </a:solidFill>
+                <a:latin typeface="Calibri" pitchFamily="34" charset="0"/>
+                <a:ea typeface="Calibri" pitchFamily="34" charset="-122"/>
+                <a:cs typeface="Calibri" pitchFamily="34" charset="-120"/>
+              </a:rPr>
+              <a:t>sample size, confound, gap</a:t>
+            </a:r>
+            <a:endParaRPr lang="en-US" sz="1200" dirty="0"/>
           </a:p>
         </p:txBody>
       </p:sp>
@@ -1894,7 +2197,7 @@
                 <a:ea typeface="Calibri" pitchFamily="34" charset="-122"/>
                 <a:cs typeface="Calibri" pitchFamily="34" charset="-120"/>
               </a:rPr>
-              <a:t>COMING IN</a:t>
+              <a:t>SHARE-OUT — 30 MIN</a:t>
             </a:r>
             <a:endParaRPr lang="en-US" sz="1200" dirty="0"/>
           </a:p>
@@ -1927,13 +2230,13 @@
             <a:r>
               <a:rPr lang="en-US" sz="2700" b="1" dirty="0">
                 <a:solidFill>
-                  <a:srgbClr val="1B3A34"/>
+                  <a:srgbClr val="1C3F60"/>
                 </a:solidFill>
                 <a:latin typeface="Georgia" pitchFamily="34" charset="0"/>
                 <a:ea typeface="Georgia" pitchFamily="34" charset="-122"/>
                 <a:cs typeface="Georgia" pitchFamily="34" charset="-120"/>
               </a:rPr>
-              <a:t>The four requirements</a:t>
+              <a:t>4–5 minutes per group</a:t>
             </a:r>
             <a:endParaRPr lang="en-US" sz="2700" dirty="0"/>
           </a:p>
@@ -1948,13 +2251,15 @@
         <p:spPr>
           <a:xfrm>
             <a:off x="640080" y="1965960"/>
-            <a:ext cx="2514600" cy="3474720"/>
-          </a:xfrm>
-          <a:prstGeom prst="rect">
-            <a:avLst/>
+            <a:ext cx="10881360" cy="1051560"/>
+          </a:xfrm>
+          <a:prstGeom prst="roundRect">
+            <a:avLst>
+              <a:gd name="adj" fmla="val 5217"/>
+            </a:avLst>
           </a:prstGeom>
           <a:solidFill>
-            <a:srgbClr val="F4F1EC"/>
+            <a:srgbClr val="1C3F60"/>
           </a:solidFill>
           <a:ln/>
         </p:spPr>
@@ -1967,8 +2272,8 @@
         </p:nvSpPr>
         <p:spPr>
           <a:xfrm>
-            <a:off x="868680" y="2194560"/>
-            <a:ext cx="2057400" cy="548640"/>
+            <a:off x="1005840" y="1965960"/>
+            <a:ext cx="10149840" cy="1051560"/>
           </a:xfrm>
           <a:prstGeom prst="rect">
             <a:avLst/>
@@ -1980,89 +2285,50 @@
           <a:bodyPr wrap="square" rtlCol="0" anchor="ctr"/>
           <a:lstStyle/>
           <a:p>
-            <a:pPr indent="0" marL="0">
-              <a:buNone/>
-            </a:pPr>
-            <a:r>
-              <a:rPr lang="en-US" sz="2600" b="1" dirty="0">
-                <a:solidFill>
-                  <a:srgbClr val="D97E3F"/>
-                </a:solidFill>
-                <a:latin typeface="Georgia" pitchFamily="34" charset="0"/>
-                <a:ea typeface="Georgia" pitchFamily="34" charset="-122"/>
-                <a:cs typeface="Georgia" pitchFamily="34" charset="-120"/>
-              </a:rPr>
-              <a:t>1</a:t>
-            </a:r>
-            <a:endParaRPr lang="en-US" sz="2600" dirty="0"/>
-          </a:p>
-        </p:txBody>
-      </p:sp>
-      <p:sp>
-        <p:nvSpPr>
-          <p:cNvPr id="6" name="Text 4"/>
-          <p:cNvSpPr/>
-          <p:nvPr/>
-        </p:nvSpPr>
-        <p:spPr>
-          <a:xfrm>
-            <a:off x="868680" y="2788920"/>
-            <a:ext cx="2057400" cy="822960"/>
-          </a:xfrm>
-          <a:prstGeom prst="rect">
-            <a:avLst/>
-          </a:prstGeom>
-          <a:noFill/>
-          <a:ln/>
-        </p:spPr>
-        <p:txBody>
-          <a:bodyPr wrap="square" rtlCol="0" anchor="t"/>
-          <a:lstStyle/>
-          <a:p>
-            <a:pPr indent="0" marL="0">
-              <a:buNone/>
-            </a:pPr>
-            <a:r>
-              <a:rPr lang="en-US" sz="1500" b="1" dirty="0">
-                <a:solidFill>
-                  <a:srgbClr val="1B3A34"/>
+            <a:pPr algn="ctr" indent="0" marL="0">
+              <a:buNone/>
+            </a:pPr>
+            <a:r>
+              <a:rPr lang="en-US" sz="1700" b="1" dirty="0">
+                <a:solidFill>
+                  <a:srgbClr val="FFFFFF"/>
                 </a:solidFill>
                 <a:latin typeface="Calibri" pitchFamily="34" charset="0"/>
                 <a:ea typeface="Calibri" pitchFamily="34" charset="-122"/>
                 <a:cs typeface="Calibri" pitchFamily="34" charset="-120"/>
               </a:rPr>
-              <a:t>A clear claim</a:t>
-            </a:r>
-            <a:endParaRPr lang="en-US" sz="1500" dirty="0"/>
-          </a:p>
-        </p:txBody>
-      </p:sp>
-      <p:sp>
-        <p:nvSpPr>
-          <p:cNvPr id="7" name="Text 5"/>
-          <p:cNvSpPr/>
-          <p:nvPr/>
-        </p:nvSpPr>
-        <p:spPr>
-          <a:xfrm>
-            <a:off x="868680" y="3520440"/>
-            <a:ext cx="2057400" cy="1737360"/>
-          </a:xfrm>
-          <a:prstGeom prst="rect">
-            <a:avLst/>
-          </a:prstGeom>
-          <a:noFill/>
-          <a:ln/>
-        </p:spPr>
-        <p:txBody>
-          <a:bodyPr wrap="square" rtlCol="0" anchor="t"/>
-          <a:lstStyle/>
-          <a:p>
-            <a:pPr indent="0" marL="0">
-              <a:buNone/>
-            </a:pPr>
-            <a:r>
-              <a:rPr lang="en-US" sz="1200" dirty="0">
+              <a:t>State the claim in the first 30 seconds. Don't bury it.</a:t>
+            </a:r>
+            <a:endParaRPr lang="en-US" sz="1700" dirty="0"/>
+          </a:p>
+        </p:txBody>
+      </p:sp>
+      <p:sp>
+        <p:nvSpPr>
+          <p:cNvPr id="6" name="Text 4"/>
+          <p:cNvSpPr/>
+          <p:nvPr/>
+        </p:nvSpPr>
+        <p:spPr>
+          <a:xfrm>
+            <a:off x="640080" y="3246120"/>
+            <a:ext cx="10058400" cy="457200"/>
+          </a:xfrm>
+          <a:prstGeom prst="rect">
+            <a:avLst/>
+          </a:prstGeom>
+          <a:noFill/>
+          <a:ln/>
+        </p:spPr>
+        <p:txBody>
+          <a:bodyPr wrap="square" rtlCol="0" anchor="ctr"/>
+          <a:lstStyle/>
+          <a:p>
+            <a:pPr indent="0" marL="0">
+              <a:buNone/>
+            </a:pPr>
+            <a:r>
+              <a:rPr lang="en-US" sz="1500" dirty="0">
                 <a:solidFill>
                   <a:srgbClr val="2A2A2A"/>
                 </a:solidFill>
@@ -2070,42 +2336,22 @@
                 <a:ea typeface="Calibri" pitchFamily="34" charset="-122"/>
                 <a:cs typeface="Calibri" pitchFamily="34" charset="-120"/>
               </a:rPr>
-              <a:t>stated as a sentence, not just a chart</a:t>
-            </a:r>
-            <a:endParaRPr lang="en-US" sz="1200" dirty="0"/>
-          </a:p>
-        </p:txBody>
-      </p:sp>
-      <p:sp>
-        <p:nvSpPr>
-          <p:cNvPr id="8" name="Shape 6"/>
-          <p:cNvSpPr/>
-          <p:nvPr/>
-        </p:nvSpPr>
-        <p:spPr>
-          <a:xfrm>
-            <a:off x="3337560" y="1965960"/>
-            <a:ext cx="2514600" cy="3474720"/>
-          </a:xfrm>
-          <a:prstGeom prst="rect">
-            <a:avLst/>
-          </a:prstGeom>
-          <a:solidFill>
-            <a:srgbClr val="F4F1EC"/>
-          </a:solidFill>
-          <a:ln/>
-        </p:spPr>
-      </p:sp>
-      <p:sp>
-        <p:nvSpPr>
-          <p:cNvPr id="9" name="Text 7"/>
-          <p:cNvSpPr/>
-          <p:nvPr/>
-        </p:nvSpPr>
-        <p:spPr>
-          <a:xfrm>
-            <a:off x="3566160" y="2194560"/>
-            <a:ext cx="2057400" cy="548640"/>
+              <a:t>1–2 questions per group from the room.</a:t>
+            </a:r>
+            <a:endParaRPr lang="en-US" sz="1500" dirty="0"/>
+          </a:p>
+        </p:txBody>
+      </p:sp>
+      <p:sp>
+        <p:nvSpPr>
+          <p:cNvPr id="7" name="Text 5"/>
+          <p:cNvSpPr/>
+          <p:nvPr/>
+        </p:nvSpPr>
+        <p:spPr>
+          <a:xfrm>
+            <a:off x="640080" y="3794760"/>
+            <a:ext cx="10058400" cy="548640"/>
           </a:xfrm>
           <a:prstGeom prst="rect">
             <a:avLst/>
@@ -2121,369 +2367,17 @@
               <a:buNone/>
             </a:pPr>
             <a:r>
-              <a:rPr lang="en-US" sz="2600" b="1" dirty="0">
-                <a:solidFill>
-                  <a:srgbClr val="D97E3F"/>
-                </a:solidFill>
-                <a:latin typeface="Georgia" pitchFamily="34" charset="0"/>
-                <a:ea typeface="Georgia" pitchFamily="34" charset="-122"/>
-                <a:cs typeface="Georgia" pitchFamily="34" charset="-120"/>
-              </a:rPr>
-              <a:t>2</a:t>
-            </a:r>
-            <a:endParaRPr lang="en-US" sz="2600" dirty="0"/>
-          </a:p>
-        </p:txBody>
-      </p:sp>
-      <p:sp>
-        <p:nvSpPr>
-          <p:cNvPr id="10" name="Text 8"/>
-          <p:cNvSpPr/>
-          <p:nvPr/>
-        </p:nvSpPr>
-        <p:spPr>
-          <a:xfrm>
-            <a:off x="3566160" y="2788920"/>
-            <a:ext cx="2057400" cy="822960"/>
-          </a:xfrm>
-          <a:prstGeom prst="rect">
-            <a:avLst/>
-          </a:prstGeom>
-          <a:noFill/>
-          <a:ln/>
-        </p:spPr>
-        <p:txBody>
-          <a:bodyPr wrap="square" rtlCol="0" anchor="t"/>
-          <a:lstStyle/>
-          <a:p>
-            <a:pPr indent="0" marL="0">
-              <a:buNone/>
-            </a:pPr>
-            <a:r>
-              <a:rPr lang="en-US" sz="1500" b="1" dirty="0">
-                <a:solidFill>
-                  <a:srgbClr val="1B3A34"/>
+              <a:rPr lang="en-US" sz="1400" i="1" dirty="0">
+                <a:solidFill>
+                  <a:srgbClr val="6B6B6B"/>
                 </a:solidFill>
                 <a:latin typeface="Calibri" pitchFamily="34" charset="0"/>
                 <a:ea typeface="Calibri" pitchFamily="34" charset="-122"/>
                 <a:cs typeface="Calibri" pitchFamily="34" charset="-120"/>
               </a:rPr>
-              <a:t>An engineered column</a:t>
-            </a:r>
-            <a:endParaRPr lang="en-US" sz="1500" dirty="0"/>
-          </a:p>
-        </p:txBody>
-      </p:sp>
-      <p:sp>
-        <p:nvSpPr>
-          <p:cNvPr id="11" name="Text 9"/>
-          <p:cNvSpPr/>
-          <p:nvPr/>
-        </p:nvSpPr>
-        <p:spPr>
-          <a:xfrm>
-            <a:off x="3566160" y="3520440"/>
-            <a:ext cx="2057400" cy="1737360"/>
-          </a:xfrm>
-          <a:prstGeom prst="rect">
-            <a:avLst/>
-          </a:prstGeom>
-          <a:noFill/>
-          <a:ln/>
-        </p:spPr>
-        <p:txBody>
-          <a:bodyPr wrap="square" rtlCol="0" anchor="t"/>
-          <a:lstStyle/>
-          <a:p>
-            <a:pPr indent="0" marL="0">
-              <a:buNone/>
-            </a:pPr>
-            <a:r>
-              <a:rPr lang="en-US" sz="1200" dirty="0">
-                <a:solidFill>
-                  <a:srgbClr val="2A2A2A"/>
-                </a:solidFill>
-                <a:latin typeface="Calibri" pitchFamily="34" charset="0"/>
-                <a:ea typeface="Calibri" pitchFamily="34" charset="-122"/>
-                <a:cs typeface="Calibri" pitchFamily="34" charset="-120"/>
-              </a:rPr>
-              <a:t>something you computed, not a raw column</a:t>
-            </a:r>
-            <a:endParaRPr lang="en-US" sz="1200" dirty="0"/>
-          </a:p>
-        </p:txBody>
-      </p:sp>
-      <p:sp>
-        <p:nvSpPr>
-          <p:cNvPr id="12" name="Shape 10"/>
-          <p:cNvSpPr/>
-          <p:nvPr/>
-        </p:nvSpPr>
-        <p:spPr>
-          <a:xfrm>
-            <a:off x="6035040" y="1965960"/>
-            <a:ext cx="2514600" cy="3474720"/>
-          </a:xfrm>
-          <a:prstGeom prst="rect">
-            <a:avLst/>
-          </a:prstGeom>
-          <a:solidFill>
-            <a:srgbClr val="F4F1EC"/>
-          </a:solidFill>
-          <a:ln/>
-        </p:spPr>
-      </p:sp>
-      <p:sp>
-        <p:nvSpPr>
-          <p:cNvPr id="13" name="Text 11"/>
-          <p:cNvSpPr/>
-          <p:nvPr/>
-        </p:nvSpPr>
-        <p:spPr>
-          <a:xfrm>
-            <a:off x="6263640" y="2194560"/>
-            <a:ext cx="2057400" cy="548640"/>
-          </a:xfrm>
-          <a:prstGeom prst="rect">
-            <a:avLst/>
-          </a:prstGeom>
-          <a:noFill/>
-          <a:ln/>
-        </p:spPr>
-        <p:txBody>
-          <a:bodyPr wrap="square" rtlCol="0" anchor="ctr"/>
-          <a:lstStyle/>
-          <a:p>
-            <a:pPr indent="0" marL="0">
-              <a:buNone/>
-            </a:pPr>
-            <a:r>
-              <a:rPr lang="en-US" sz="2600" b="1" dirty="0">
-                <a:solidFill>
-                  <a:srgbClr val="D97E3F"/>
-                </a:solidFill>
-                <a:latin typeface="Georgia" pitchFamily="34" charset="0"/>
-                <a:ea typeface="Georgia" pitchFamily="34" charset="-122"/>
-                <a:cs typeface="Georgia" pitchFamily="34" charset="-120"/>
-              </a:rPr>
-              <a:t>3</a:t>
-            </a:r>
-            <a:endParaRPr lang="en-US" sz="2600" dirty="0"/>
-          </a:p>
-        </p:txBody>
-      </p:sp>
-      <p:sp>
-        <p:nvSpPr>
-          <p:cNvPr id="14" name="Text 12"/>
-          <p:cNvSpPr/>
-          <p:nvPr/>
-        </p:nvSpPr>
-        <p:spPr>
-          <a:xfrm>
-            <a:off x="6263640" y="2788920"/>
-            <a:ext cx="2057400" cy="822960"/>
-          </a:xfrm>
-          <a:prstGeom prst="rect">
-            <a:avLst/>
-          </a:prstGeom>
-          <a:noFill/>
-          <a:ln/>
-        </p:spPr>
-        <p:txBody>
-          <a:bodyPr wrap="square" rtlCol="0" anchor="t"/>
-          <a:lstStyle/>
-          <a:p>
-            <a:pPr indent="0" marL="0">
-              <a:buNone/>
-            </a:pPr>
-            <a:r>
-              <a:rPr lang="en-US" sz="1500" b="1" dirty="0">
-                <a:solidFill>
-                  <a:srgbClr val="1B3A34"/>
-                </a:solidFill>
-                <a:latin typeface="Calibri" pitchFamily="34" charset="0"/>
-                <a:ea typeface="Calibri" pitchFamily="34" charset="-122"/>
-                <a:cs typeface="Calibri" pitchFamily="34" charset="-120"/>
-              </a:rPr>
-              <a:t>Excel + Power BI</a:t>
-            </a:r>
-            <a:endParaRPr lang="en-US" sz="1500" dirty="0"/>
-          </a:p>
-        </p:txBody>
-      </p:sp>
-      <p:sp>
-        <p:nvSpPr>
-          <p:cNvPr id="15" name="Text 13"/>
-          <p:cNvSpPr/>
-          <p:nvPr/>
-        </p:nvSpPr>
-        <p:spPr>
-          <a:xfrm>
-            <a:off x="6263640" y="3520440"/>
-            <a:ext cx="2057400" cy="1737360"/>
-          </a:xfrm>
-          <a:prstGeom prst="rect">
-            <a:avLst/>
-          </a:prstGeom>
-          <a:noFill/>
-          <a:ln/>
-        </p:spPr>
-        <p:txBody>
-          <a:bodyPr wrap="square" rtlCol="0" anchor="t"/>
-          <a:lstStyle/>
-          <a:p>
-            <a:pPr indent="0" marL="0">
-              <a:buNone/>
-            </a:pPr>
-            <a:r>
-              <a:rPr lang="en-US" sz="1200" dirty="0">
-                <a:solidFill>
-                  <a:srgbClr val="2A2A2A"/>
-                </a:solidFill>
-                <a:latin typeface="Calibri" pitchFamily="34" charset="0"/>
-                <a:ea typeface="Calibri" pitchFamily="34" charset="-122"/>
-                <a:cs typeface="Calibri" pitchFamily="34" charset="-120"/>
-              </a:rPr>
-              <a:t>the analysis and the dashboard, both</a:t>
-            </a:r>
-            <a:endParaRPr lang="en-US" sz="1200" dirty="0"/>
-          </a:p>
-        </p:txBody>
-      </p:sp>
-      <p:sp>
-        <p:nvSpPr>
-          <p:cNvPr id="16" name="Shape 14"/>
-          <p:cNvSpPr/>
-          <p:nvPr/>
-        </p:nvSpPr>
-        <p:spPr>
-          <a:xfrm>
-            <a:off x="8732520" y="1965960"/>
-            <a:ext cx="2514600" cy="3474720"/>
-          </a:xfrm>
-          <a:prstGeom prst="rect">
-            <a:avLst/>
-          </a:prstGeom>
-          <a:solidFill>
-            <a:srgbClr val="F4F1EC"/>
-          </a:solidFill>
-          <a:ln/>
-        </p:spPr>
-      </p:sp>
-      <p:sp>
-        <p:nvSpPr>
-          <p:cNvPr id="17" name="Text 15"/>
-          <p:cNvSpPr/>
-          <p:nvPr/>
-        </p:nvSpPr>
-        <p:spPr>
-          <a:xfrm>
-            <a:off x="8961120" y="2194560"/>
-            <a:ext cx="2057400" cy="548640"/>
-          </a:xfrm>
-          <a:prstGeom prst="rect">
-            <a:avLst/>
-          </a:prstGeom>
-          <a:noFill/>
-          <a:ln/>
-        </p:spPr>
-        <p:txBody>
-          <a:bodyPr wrap="square" rtlCol="0" anchor="ctr"/>
-          <a:lstStyle/>
-          <a:p>
-            <a:pPr indent="0" marL="0">
-              <a:buNone/>
-            </a:pPr>
-            <a:r>
-              <a:rPr lang="en-US" sz="2600" b="1" dirty="0">
-                <a:solidFill>
-                  <a:srgbClr val="D97E3F"/>
-                </a:solidFill>
-                <a:latin typeface="Georgia" pitchFamily="34" charset="0"/>
-                <a:ea typeface="Georgia" pitchFamily="34" charset="-122"/>
-                <a:cs typeface="Georgia" pitchFamily="34" charset="-120"/>
-              </a:rPr>
-              <a:t>4</a:t>
-            </a:r>
-            <a:endParaRPr lang="en-US" sz="2600" dirty="0"/>
-          </a:p>
-        </p:txBody>
-      </p:sp>
-      <p:sp>
-        <p:nvSpPr>
-          <p:cNvPr id="18" name="Text 16"/>
-          <p:cNvSpPr/>
-          <p:nvPr/>
-        </p:nvSpPr>
-        <p:spPr>
-          <a:xfrm>
-            <a:off x="8961120" y="2788920"/>
-            <a:ext cx="2057400" cy="822960"/>
-          </a:xfrm>
-          <a:prstGeom prst="rect">
-            <a:avLst/>
-          </a:prstGeom>
-          <a:noFill/>
-          <a:ln/>
-        </p:spPr>
-        <p:txBody>
-          <a:bodyPr wrap="square" rtlCol="0" anchor="t"/>
-          <a:lstStyle/>
-          <a:p>
-            <a:pPr indent="0" marL="0">
-              <a:buNone/>
-            </a:pPr>
-            <a:r>
-              <a:rPr lang="en-US" sz="1500" b="1" dirty="0">
-                <a:solidFill>
-                  <a:srgbClr val="1B3A34"/>
-                </a:solidFill>
-                <a:latin typeface="Calibri" pitchFamily="34" charset="0"/>
-                <a:ea typeface="Calibri" pitchFamily="34" charset="-122"/>
-                <a:cs typeface="Calibri" pitchFamily="34" charset="-120"/>
-              </a:rPr>
-              <a:t>A named limitation</a:t>
-            </a:r>
-            <a:endParaRPr lang="en-US" sz="1500" dirty="0"/>
-          </a:p>
-        </p:txBody>
-      </p:sp>
-      <p:sp>
-        <p:nvSpPr>
-          <p:cNvPr id="19" name="Text 17"/>
-          <p:cNvSpPr/>
-          <p:nvPr/>
-        </p:nvSpPr>
-        <p:spPr>
-          <a:xfrm>
-            <a:off x="8961120" y="3520440"/>
-            <a:ext cx="2057400" cy="1737360"/>
-          </a:xfrm>
-          <a:prstGeom prst="rect">
-            <a:avLst/>
-          </a:prstGeom>
-          <a:noFill/>
-          <a:ln/>
-        </p:spPr>
-        <p:txBody>
-          <a:bodyPr wrap="square" rtlCol="0" anchor="t"/>
-          <a:lstStyle/>
-          <a:p>
-            <a:pPr indent="0" marL="0">
-              <a:buNone/>
-            </a:pPr>
-            <a:r>
-              <a:rPr lang="en-US" sz="1200" dirty="0">
-                <a:solidFill>
-                  <a:srgbClr val="2A2A2A"/>
-                </a:solidFill>
-                <a:latin typeface="Calibri" pitchFamily="34" charset="0"/>
-                <a:ea typeface="Calibri" pitchFamily="34" charset="-122"/>
-                <a:cs typeface="Calibri" pitchFamily="34" charset="-120"/>
-              </a:rPr>
-              <a:t>small sample, confound, missing variable</a:t>
-            </a:r>
-            <a:endParaRPr lang="en-US" sz="1200" dirty="0"/>
+              <a:t>Not a competition. Five or six different approaches to the same dataset is the point.</a:t>
+            </a:r>
+            <a:endParaRPr lang="en-US" sz="1400" dirty="0"/>
           </a:p>
         </p:txBody>
       </p:sp>
@@ -2552,7 +2446,7 @@
                 <a:ea typeface="Calibri" pitchFamily="34" charset="-122"/>
                 <a:cs typeface="Calibri" pitchFamily="34" charset="-120"/>
               </a:rPr>
-              <a:t>SHARE-OUT — 30 MIN</a:t>
+              <a:t>RETROSPECTIVE — 20 MIN</a:t>
             </a:r>
             <a:endParaRPr lang="en-US" sz="1200" dirty="0"/>
           </a:p>
@@ -2585,13 +2479,13 @@
             <a:r>
               <a:rPr lang="en-US" sz="2700" b="1" dirty="0">
                 <a:solidFill>
-                  <a:srgbClr val="1B3A34"/>
+                  <a:srgbClr val="1C3F60"/>
                 </a:solidFill>
                 <a:latin typeface="Georgia" pitchFamily="34" charset="0"/>
                 <a:ea typeface="Georgia" pitchFamily="34" charset="-122"/>
                 <a:cs typeface="Georgia" pitchFamily="34" charset="-120"/>
               </a:rPr>
-              <a:t>4-5 minutes per group</a:t>
+              <a:t>Whole branch, in order</a:t>
             </a:r>
             <a:endParaRPr lang="en-US" sz="2700" dirty="0"/>
           </a:p>
@@ -2599,25 +2493,42 @@
       </p:sp>
       <p:sp>
         <p:nvSpPr>
-          <p:cNvPr id="4" name="Shape 2"/>
+          <p:cNvPr id="4" name="Text 2"/>
           <p:cNvSpPr/>
           <p:nvPr/>
         </p:nvSpPr>
         <p:spPr>
           <a:xfrm>
             <a:off x="640080" y="2011680"/>
-            <a:ext cx="10881360" cy="1097280"/>
-          </a:xfrm>
-          <a:prstGeom prst="roundRect">
-            <a:avLst>
-              <a:gd name="adj" fmla="val 5000"/>
-            </a:avLst>
-          </a:prstGeom>
-          <a:solidFill>
-            <a:srgbClr val="1B3A34"/>
-          </a:solidFill>
-          <a:ln/>
-        </p:spPr>
+            <a:ext cx="548640" cy="640080"/>
+          </a:xfrm>
+          <a:prstGeom prst="rect">
+            <a:avLst/>
+          </a:prstGeom>
+          <a:noFill/>
+          <a:ln/>
+        </p:spPr>
+        <p:txBody>
+          <a:bodyPr wrap="square" rtlCol="0" anchor="ctr"/>
+          <a:lstStyle/>
+          <a:p>
+            <a:pPr indent="0" marL="0">
+              <a:buNone/>
+            </a:pPr>
+            <a:r>
+              <a:rPr lang="en-US" sz="2600" b="1" dirty="0">
+                <a:solidFill>
+                  <a:srgbClr val="D97E3F"/>
+                </a:solidFill>
+                <a:latin typeface="Georgia" pitchFamily="34" charset="0"/>
+                <a:ea typeface="Georgia" pitchFamily="34" charset="-122"/>
+                <a:cs typeface="Georgia" pitchFamily="34" charset="-120"/>
+              </a:rPr>
+              <a:t>1</a:t>
+            </a:r>
+            <a:endParaRPr lang="en-US" sz="2600" dirty="0"/>
+          </a:p>
+        </p:txBody>
       </p:sp>
       <p:sp>
         <p:nvSpPr>
@@ -2627,8 +2538,8 @@
         </p:nvSpPr>
         <p:spPr>
           <a:xfrm>
-            <a:off x="1005840" y="2011680"/>
-            <a:ext cx="10149840" cy="1097280"/>
+            <a:off x="1371600" y="2057400"/>
+            <a:ext cx="9601200" cy="640080"/>
           </a:xfrm>
           <a:prstGeom prst="rect">
             <a:avLst/>
@@ -2640,21 +2551,21 @@
           <a:bodyPr wrap="square" rtlCol="0" anchor="ctr"/>
           <a:lstStyle/>
           <a:p>
-            <a:pPr algn="ctr" indent="0" marL="0">
-              <a:buNone/>
-            </a:pPr>
-            <a:r>
-              <a:rPr lang="en-US" sz="1700" b="1" dirty="0">
-                <a:solidFill>
-                  <a:srgbClr val="FFFFFF"/>
+            <a:pPr indent="0" marL="0">
+              <a:buNone/>
+            </a:pPr>
+            <a:r>
+              <a:rPr lang="en-US" sz="1900" dirty="0">
+                <a:solidFill>
+                  <a:srgbClr val="1C3F60"/>
                 </a:solidFill>
                 <a:latin typeface="Calibri" pitchFamily="34" charset="0"/>
                 <a:ea typeface="Calibri" pitchFamily="34" charset="-122"/>
                 <a:cs typeface="Calibri" pitchFamily="34" charset="-120"/>
               </a:rPr>
-              <a:t>“Here's what we found, and here's the one number that convinced us.”</a:t>
-            </a:r>
-            <a:endParaRPr lang="en-US" sz="1700" dirty="0"/>
+              <a:t>What felt hard this cycle?</a:t>
+            </a:r>
+            <a:endParaRPr lang="en-US" sz="1900" dirty="0"/>
           </a:p>
         </p:txBody>
       </p:sp>
@@ -2666,8 +2577,8 @@
         </p:nvSpPr>
         <p:spPr>
           <a:xfrm>
-            <a:off x="640080" y="3337560"/>
-            <a:ext cx="10058400" cy="457200"/>
+            <a:off x="640080" y="2926080"/>
+            <a:ext cx="548640" cy="640080"/>
           </a:xfrm>
           <a:prstGeom prst="rect">
             <a:avLst/>
@@ -2683,30 +2594,69 @@
               <a:buNone/>
             </a:pPr>
             <a:r>
-              <a:rPr lang="en-US" sz="1400" dirty="0">
-                <a:solidFill>
-                  <a:srgbClr val="2A2A2A"/>
+              <a:rPr lang="en-US" sz="2600" b="1" dirty="0">
+                <a:solidFill>
+                  <a:srgbClr val="D97E3F"/>
+                </a:solidFill>
+                <a:latin typeface="Georgia" pitchFamily="34" charset="0"/>
+                <a:ea typeface="Georgia" pitchFamily="34" charset="-122"/>
+                <a:cs typeface="Georgia" pitchFamily="34" charset="-120"/>
+              </a:rPr>
+              <a:t>2</a:t>
+            </a:r>
+            <a:endParaRPr lang="en-US" sz="2600" dirty="0"/>
+          </a:p>
+        </p:txBody>
+      </p:sp>
+      <p:sp>
+        <p:nvSpPr>
+          <p:cNvPr id="7" name="Text 5"/>
+          <p:cNvSpPr/>
+          <p:nvPr/>
+        </p:nvSpPr>
+        <p:spPr>
+          <a:xfrm>
+            <a:off x="1371600" y="2971800"/>
+            <a:ext cx="9601200" cy="640080"/>
+          </a:xfrm>
+          <a:prstGeom prst="rect">
+            <a:avLst/>
+          </a:prstGeom>
+          <a:noFill/>
+          <a:ln/>
+        </p:spPr>
+        <p:txBody>
+          <a:bodyPr wrap="square" rtlCol="0" anchor="ctr"/>
+          <a:lstStyle/>
+          <a:p>
+            <a:pPr indent="0" marL="0">
+              <a:buNone/>
+            </a:pPr>
+            <a:r>
+              <a:rPr lang="en-US" sz="1900" dirty="0">
+                <a:solidFill>
+                  <a:srgbClr val="1C3F60"/>
                 </a:solidFill>
                 <a:latin typeface="Calibri" pitchFamily="34" charset="0"/>
                 <a:ea typeface="Calibri" pitchFamily="34" charset="-122"/>
                 <a:cs typeface="Calibri" pitchFamily="34" charset="-120"/>
               </a:rPr>
-              <a:t>State the claim in the first 30 seconds. Don't bury it at the end.</a:t>
-            </a:r>
-            <a:endParaRPr lang="en-US" sz="1400" dirty="0"/>
-          </a:p>
-        </p:txBody>
-      </p:sp>
-      <p:sp>
-        <p:nvSpPr>
-          <p:cNvPr id="7" name="Text 5"/>
-          <p:cNvSpPr/>
-          <p:nvPr/>
-        </p:nvSpPr>
-        <p:spPr>
-          <a:xfrm>
-            <a:off x="640080" y="3886200"/>
-            <a:ext cx="10058400" cy="822960"/>
+              <a:t>What's one thing that clicked?</a:t>
+            </a:r>
+            <a:endParaRPr lang="en-US" sz="1900" dirty="0"/>
+          </a:p>
+        </p:txBody>
+      </p:sp>
+      <p:sp>
+        <p:nvSpPr>
+          <p:cNvPr id="8" name="Text 6"/>
+          <p:cNvSpPr/>
+          <p:nvPr/>
+        </p:nvSpPr>
+        <p:spPr>
+          <a:xfrm>
+            <a:off x="640080" y="3840480"/>
+            <a:ext cx="548640" cy="640080"/>
           </a:xfrm>
           <a:prstGeom prst="rect">
             <a:avLst/>
@@ -2722,17 +2672,95 @@
               <a:buNone/>
             </a:pPr>
             <a:r>
-              <a:rPr lang="en-US" sz="1400" i="1" dirty="0">
-                <a:solidFill>
-                  <a:srgbClr val="6B6B6B"/>
+              <a:rPr lang="en-US" sz="2600" b="1" dirty="0">
+                <a:solidFill>
+                  <a:srgbClr val="D97E3F"/>
+                </a:solidFill>
+                <a:latin typeface="Georgia" pitchFamily="34" charset="0"/>
+                <a:ea typeface="Georgia" pitchFamily="34" charset="-122"/>
+                <a:cs typeface="Georgia" pitchFamily="34" charset="-120"/>
+              </a:rPr>
+              <a:t>3</a:t>
+            </a:r>
+            <a:endParaRPr lang="en-US" sz="2600" dirty="0"/>
+          </a:p>
+        </p:txBody>
+      </p:sp>
+      <p:sp>
+        <p:nvSpPr>
+          <p:cNvPr id="9" name="Text 7"/>
+          <p:cNvSpPr/>
+          <p:nvPr/>
+        </p:nvSpPr>
+        <p:spPr>
+          <a:xfrm>
+            <a:off x="1371600" y="3886200"/>
+            <a:ext cx="9601200" cy="640080"/>
+          </a:xfrm>
+          <a:prstGeom prst="rect">
+            <a:avLst/>
+          </a:prstGeom>
+          <a:noFill/>
+          <a:ln/>
+        </p:spPr>
+        <p:txBody>
+          <a:bodyPr wrap="square" rtlCol="0" anchor="ctr"/>
+          <a:lstStyle/>
+          <a:p>
+            <a:pPr indent="0" marL="0">
+              <a:buNone/>
+            </a:pPr>
+            <a:r>
+              <a:rPr lang="en-US" sz="1900" dirty="0">
+                <a:solidFill>
+                  <a:srgbClr val="1C3F60"/>
                 </a:solidFill>
                 <a:latin typeface="Calibri" pitchFamily="34" charset="0"/>
                 <a:ea typeface="Calibri" pitchFamily="34" charset="-122"/>
                 <a:cs typeface="Calibri" pitchFamily="34" charset="-120"/>
               </a:rPr>
-              <a:t>1–2 questions per group from the room. This is not a competition — 5–6 different approaches to the same dataset is the whole point.</a:t>
-            </a:r>
-            <a:endParaRPr lang="en-US" sz="1400" dirty="0"/>
+              <a:t>What do you want more practice on before SQL?</a:t>
+            </a:r>
+            <a:endParaRPr lang="en-US" sz="1900" dirty="0"/>
+          </a:p>
+        </p:txBody>
+      </p:sp>
+      <p:sp>
+        <p:nvSpPr>
+          <p:cNvPr id="10" name="Text 8"/>
+          <p:cNvSpPr/>
+          <p:nvPr/>
+        </p:nvSpPr>
+        <p:spPr>
+          <a:xfrm>
+            <a:off x="640080" y="4937760"/>
+            <a:ext cx="10058400" cy="457200"/>
+          </a:xfrm>
+          <a:prstGeom prst="rect">
+            <a:avLst/>
+          </a:prstGeom>
+          <a:noFill/>
+          <a:ln/>
+        </p:spPr>
+        <p:txBody>
+          <a:bodyPr wrap="square" rtlCol="0" anchor="ctr"/>
+          <a:lstStyle/>
+          <a:p>
+            <a:pPr indent="0" marL="0">
+              <a:buNone/>
+            </a:pPr>
+            <a:r>
+              <a:rPr lang="en-US" sz="1300" i="1" dirty="0">
+                <a:solidFill>
+                  <a:srgbClr val="6B6B6B"/>
+                </a:solidFill>
+                <a:latin typeface="Calibri" pitchFamily="34" charset="0"/>
+                <a:ea typeface="Calibri" pitchFamily="34" charset="-122"/>
+                <a:cs typeface="Calibri" pitchFamily="34" charset="-120"/>
+              </a:rPr>
+              <a:t>Officers: write these down. Real input, not a formality.</a:t>
+            </a:r>
+            <a:endParaRPr lang="en-US" sz="1300" dirty="0"/>
           </a:p>
         </p:txBody>
       </p:sp>
@@ -2801,7 +2829,7 @@
                 <a:ea typeface="Calibri" pitchFamily="34" charset="-122"/>
                 <a:cs typeface="Calibri" pitchFamily="34" charset="-120"/>
               </a:rPr>
-              <a:t>RETROSPECTIVE — 20 MIN</a:t>
+              <a:t>LOOKING AHEAD</a:t>
             </a:r>
             <a:endParaRPr lang="en-US" sz="1200" dirty="0"/>
           </a:p>
@@ -2834,13 +2862,13 @@
             <a:r>
               <a:rPr lang="en-US" sz="2700" b="1" dirty="0">
                 <a:solidFill>
-                  <a:srgbClr val="1B3A34"/>
+                  <a:srgbClr val="1C3F60"/>
                 </a:solidFill>
                 <a:latin typeface="Georgia" pitchFamily="34" charset="0"/>
                 <a:ea typeface="Georgia" pitchFamily="34" charset="-122"/>
                 <a:cs typeface="Georgia" pitchFamily="34" charset="-120"/>
               </a:rPr>
-              <a:t>Whole-branch discussion, in order</a:t>
+              <a:t>Month one → month two</a:t>
             </a:r>
             <a:endParaRPr lang="en-US" sz="2700" dirty="0"/>
           </a:p>
@@ -2848,14 +2876,34 @@
       </p:sp>
       <p:sp>
         <p:nvSpPr>
-          <p:cNvPr id="4" name="Text 2"/>
-          <p:cNvSpPr/>
-          <p:nvPr/>
-        </p:nvSpPr>
-        <p:spPr>
-          <a:xfrm>
-            <a:off x="640080" y="2103120"/>
-            <a:ext cx="548640" cy="640080"/>
+          <p:cNvPr id="4" name="Shape 2"/>
+          <p:cNvSpPr/>
+          <p:nvPr/>
+        </p:nvSpPr>
+        <p:spPr>
+          <a:xfrm>
+            <a:off x="640080" y="1965960"/>
+            <a:ext cx="5212080" cy="3017520"/>
+          </a:xfrm>
+          <a:prstGeom prst="rect">
+            <a:avLst/>
+          </a:prstGeom>
+          <a:solidFill>
+            <a:srgbClr val="F4F1EC"/>
+          </a:solidFill>
+          <a:ln/>
+        </p:spPr>
+      </p:sp>
+      <p:sp>
+        <p:nvSpPr>
+          <p:cNvPr id="5" name="Text 3"/>
+          <p:cNvSpPr/>
+          <p:nvPr/>
+        </p:nvSpPr>
+        <p:spPr>
+          <a:xfrm>
+            <a:off x="960120" y="2194560"/>
+            <a:ext cx="4572000" cy="320040"/>
           </a:xfrm>
           <a:prstGeom prst="rect">
             <a:avLst/>
@@ -2871,56 +2919,17 @@
               <a:buNone/>
             </a:pPr>
             <a:r>
-              <a:rPr lang="en-US" sz="2600" b="1" dirty="0">
+              <a:rPr lang="en-US" sz="1100" b="1" spc="150" kern="0" dirty="0">
                 <a:solidFill>
                   <a:srgbClr val="D97E3F"/>
-                </a:solidFill>
-                <a:latin typeface="Georgia" pitchFamily="34" charset="0"/>
-                <a:ea typeface="Georgia" pitchFamily="34" charset="-122"/>
-                <a:cs typeface="Georgia" pitchFamily="34" charset="-120"/>
-              </a:rPr>
-              <a:t>1</a:t>
-            </a:r>
-            <a:endParaRPr lang="en-US" sz="2600" dirty="0"/>
-          </a:p>
-        </p:txBody>
-      </p:sp>
-      <p:sp>
-        <p:nvSpPr>
-          <p:cNvPr id="5" name="Text 3"/>
-          <p:cNvSpPr/>
-          <p:nvPr/>
-        </p:nvSpPr>
-        <p:spPr>
-          <a:xfrm>
-            <a:off x="1371600" y="2148840"/>
-            <a:ext cx="9601200" cy="640080"/>
-          </a:xfrm>
-          <a:prstGeom prst="rect">
-            <a:avLst/>
-          </a:prstGeom>
-          <a:noFill/>
-          <a:ln/>
-        </p:spPr>
-        <p:txBody>
-          <a:bodyPr wrap="square" rtlCol="0" anchor="ctr"/>
-          <a:lstStyle/>
-          <a:p>
-            <a:pPr indent="0" marL="0">
-              <a:buNone/>
-            </a:pPr>
-            <a:r>
-              <a:rPr lang="en-US" sz="1900" dirty="0">
-                <a:solidFill>
-                  <a:srgbClr val="1B3A34"/>
                 </a:solidFill>
                 <a:latin typeface="Calibri" pitchFamily="34" charset="0"/>
                 <a:ea typeface="Calibri" pitchFamily="34" charset="-122"/>
                 <a:cs typeface="Calibri" pitchFamily="34" charset="-120"/>
               </a:rPr>
-              <a:t>What felt hard this cycle?</a:t>
-            </a:r>
-            <a:endParaRPr lang="en-US" sz="1900" dirty="0"/>
+              <a:t>MONTH ONE</a:t>
+            </a:r>
+            <a:endParaRPr lang="en-US" sz="1100" dirty="0"/>
           </a:p>
         </p:txBody>
       </p:sp>
@@ -2932,75 +2941,56 @@
         </p:nvSpPr>
         <p:spPr>
           <a:xfrm>
-            <a:off x="640080" y="3017520"/>
-            <a:ext cx="548640" cy="640080"/>
-          </a:xfrm>
-          <a:prstGeom prst="rect">
-            <a:avLst/>
-          </a:prstGeom>
-          <a:noFill/>
-          <a:ln/>
-        </p:spPr>
-        <p:txBody>
-          <a:bodyPr wrap="square" rtlCol="0" anchor="ctr"/>
-          <a:lstStyle/>
-          <a:p>
-            <a:pPr indent="0" marL="0">
-              <a:buNone/>
-            </a:pPr>
-            <a:r>
-              <a:rPr lang="en-US" sz="2600" b="1" dirty="0">
-                <a:solidFill>
-                  <a:srgbClr val="D97E3F"/>
-                </a:solidFill>
-                <a:latin typeface="Georgia" pitchFamily="34" charset="0"/>
-                <a:ea typeface="Georgia" pitchFamily="34" charset="-122"/>
-                <a:cs typeface="Georgia" pitchFamily="34" charset="-120"/>
-              </a:rPr>
-              <a:t>2</a:t>
-            </a:r>
-            <a:endParaRPr lang="en-US" sz="2600" dirty="0"/>
-          </a:p>
-        </p:txBody>
-      </p:sp>
-      <p:sp>
-        <p:nvSpPr>
-          <p:cNvPr id="7" name="Text 5"/>
-          <p:cNvSpPr/>
-          <p:nvPr/>
-        </p:nvSpPr>
-        <p:spPr>
-          <a:xfrm>
-            <a:off x="1371600" y="3063240"/>
-            <a:ext cx="9601200" cy="640080"/>
-          </a:xfrm>
-          <a:prstGeom prst="rect">
-            <a:avLst/>
-          </a:prstGeom>
-          <a:noFill/>
-          <a:ln/>
-        </p:spPr>
-        <p:txBody>
-          <a:bodyPr wrap="square" rtlCol="0" anchor="ctr"/>
-          <a:lstStyle/>
-          <a:p>
-            <a:pPr indent="0" marL="0">
-              <a:buNone/>
-            </a:pPr>
-            <a:r>
-              <a:rPr lang="en-US" sz="1900" dirty="0">
-                <a:solidFill>
-                  <a:srgbClr val="1B3A34"/>
+            <a:off x="960120" y="2560320"/>
+            <a:ext cx="4572000" cy="1371600"/>
+          </a:xfrm>
+          <a:prstGeom prst="rect">
+            <a:avLst/>
+          </a:prstGeom>
+          <a:noFill/>
+          <a:ln/>
+        </p:spPr>
+        <p:txBody>
+          <a:bodyPr wrap="square" rtlCol="0" anchor="t"/>
+          <a:lstStyle/>
+          <a:p>
+            <a:pPr indent="0" marL="0">
+              <a:buNone/>
+            </a:pPr>
+            <a:r>
+              <a:rPr lang="en-US" sz="1500" dirty="0">
+                <a:solidFill>
+                  <a:srgbClr val="2A2A2A"/>
                 </a:solidFill>
                 <a:latin typeface="Calibri" pitchFamily="34" charset="0"/>
                 <a:ea typeface="Calibri" pitchFamily="34" charset="-122"/>
                 <a:cs typeface="Calibri" pitchFamily="34" charset="-120"/>
               </a:rPr>
-              <a:t>What's one thing that clicked?</a:t>
-            </a:r>
-            <a:endParaRPr lang="en-US" sz="1900" dirty="0"/>
-          </a:p>
-        </p:txBody>
+              <a:t>Comfortable enough with tools to ask a real question and defend it.</a:t>
+            </a:r>
+            <a:endParaRPr lang="en-US" sz="1500" dirty="0"/>
+          </a:p>
+        </p:txBody>
+      </p:sp>
+      <p:sp>
+        <p:nvSpPr>
+          <p:cNvPr id="7" name="Shape 5"/>
+          <p:cNvSpPr/>
+          <p:nvPr/>
+        </p:nvSpPr>
+        <p:spPr>
+          <a:xfrm>
+            <a:off x="6172200" y="1965960"/>
+            <a:ext cx="5349240" cy="3017520"/>
+          </a:xfrm>
+          <a:prstGeom prst="rect">
+            <a:avLst/>
+          </a:prstGeom>
+          <a:solidFill>
+            <a:srgbClr val="1C3F60"/>
+          </a:solidFill>
+          <a:ln/>
+        </p:spPr>
       </p:sp>
       <p:sp>
         <p:nvSpPr>
@@ -3010,8 +3000,8 @@
         </p:nvSpPr>
         <p:spPr>
           <a:xfrm>
-            <a:off x="640080" y="3931920"/>
-            <a:ext cx="548640" cy="640080"/>
+            <a:off x="6492240" y="2194560"/>
+            <a:ext cx="4754880" cy="320040"/>
           </a:xfrm>
           <a:prstGeom prst="rect">
             <a:avLst/>
@@ -3027,95 +3017,56 @@
               <a:buNone/>
             </a:pPr>
             <a:r>
-              <a:rPr lang="en-US" sz="2600" b="1" dirty="0">
+              <a:rPr lang="en-US" sz="1100" b="1" spc="150" kern="0" dirty="0">
                 <a:solidFill>
                   <a:srgbClr val="D97E3F"/>
-                </a:solidFill>
-                <a:latin typeface="Georgia" pitchFamily="34" charset="0"/>
-                <a:ea typeface="Georgia" pitchFamily="34" charset="-122"/>
-                <a:cs typeface="Georgia" pitchFamily="34" charset="-120"/>
-              </a:rPr>
-              <a:t>3</a:t>
-            </a:r>
-            <a:endParaRPr lang="en-US" sz="2600" dirty="0"/>
-          </a:p>
-        </p:txBody>
-      </p:sp>
-      <p:sp>
-        <p:nvSpPr>
-          <p:cNvPr id="9" name="Text 7"/>
-          <p:cNvSpPr/>
-          <p:nvPr/>
-        </p:nvSpPr>
-        <p:spPr>
-          <a:xfrm>
-            <a:off x="1371600" y="3977640"/>
-            <a:ext cx="9601200" cy="640080"/>
-          </a:xfrm>
-          <a:prstGeom prst="rect">
-            <a:avLst/>
-          </a:prstGeom>
-          <a:noFill/>
-          <a:ln/>
-        </p:spPr>
-        <p:txBody>
-          <a:bodyPr wrap="square" rtlCol="0" anchor="ctr"/>
-          <a:lstStyle/>
-          <a:p>
-            <a:pPr indent="0" marL="0">
-              <a:buNone/>
-            </a:pPr>
-            <a:r>
-              <a:rPr lang="en-US" sz="1900" dirty="0">
-                <a:solidFill>
-                  <a:srgbClr val="1B3A34"/>
                 </a:solidFill>
                 <a:latin typeface="Calibri" pitchFamily="34" charset="0"/>
                 <a:ea typeface="Calibri" pitchFamily="34" charset="-122"/>
                 <a:cs typeface="Calibri" pitchFamily="34" charset="-120"/>
               </a:rPr>
-              <a:t>What do you want more practice on before SQL?</a:t>
-            </a:r>
-            <a:endParaRPr lang="en-US" sz="1900" dirty="0"/>
-          </a:p>
-        </p:txBody>
-      </p:sp>
-      <p:sp>
-        <p:nvSpPr>
-          <p:cNvPr id="10" name="Text 8"/>
-          <p:cNvSpPr/>
-          <p:nvPr/>
-        </p:nvSpPr>
-        <p:spPr>
-          <a:xfrm>
-            <a:off x="640080" y="5029200"/>
-            <a:ext cx="10058400" cy="457200"/>
-          </a:xfrm>
-          <a:prstGeom prst="rect">
-            <a:avLst/>
-          </a:prstGeom>
-          <a:noFill/>
-          <a:ln/>
-        </p:spPr>
-        <p:txBody>
-          <a:bodyPr wrap="square" rtlCol="0" anchor="ctr"/>
-          <a:lstStyle/>
-          <a:p>
-            <a:pPr indent="0" marL="0">
-              <a:buNone/>
-            </a:pPr>
-            <a:r>
-              <a:rPr lang="en-US" sz="1300" i="1" dirty="0">
-                <a:solidFill>
-                  <a:srgbClr val="6B6B6B"/>
+              <a:t>MONTH TWO</a:t>
+            </a:r>
+            <a:endParaRPr lang="en-US" sz="1100" dirty="0"/>
+          </a:p>
+        </p:txBody>
+      </p:sp>
+      <p:sp>
+        <p:nvSpPr>
+          <p:cNvPr id="9" name="Text 7"/>
+          <p:cNvSpPr/>
+          <p:nvPr/>
+        </p:nvSpPr>
+        <p:spPr>
+          <a:xfrm>
+            <a:off x="6492240" y="2560320"/>
+            <a:ext cx="4754880" cy="1554480"/>
+          </a:xfrm>
+          <a:prstGeom prst="rect">
+            <a:avLst/>
+          </a:prstGeom>
+          <a:noFill/>
+          <a:ln/>
+        </p:spPr>
+        <p:txBody>
+          <a:bodyPr wrap="square" rtlCol="0" anchor="t"/>
+          <a:lstStyle/>
+          <a:p>
+            <a:pPr indent="0" marL="0">
+              <a:buNone/>
+            </a:pPr>
+            <a:r>
+              <a:rPr lang="en-US" sz="1500" dirty="0">
+                <a:solidFill>
+                  <a:srgbClr val="FFFFFF"/>
                 </a:solidFill>
                 <a:latin typeface="Calibri" pitchFamily="34" charset="0"/>
                 <a:ea typeface="Calibri" pitchFamily="34" charset="-122"/>
                 <a:cs typeface="Calibri" pitchFamily="34" charset="-120"/>
               </a:rPr>
-              <a:t>Officers: write these down. Real input for pacing the SQL block — not a formality.</a:t>
-            </a:r>
-            <a:endParaRPr lang="en-US" sz="1300" dirty="0"/>
+              <a:t>SQL — same instinct, a different way into the data. The most-requested skill in analyst postings.</a:t>
+            </a:r>
+            <a:endParaRPr lang="en-US" sz="1500" dirty="0"/>
           </a:p>
         </p:txBody>
       </p:sp>
@@ -3133,7 +3084,7 @@
     <p:bg>
       <p:bgPr>
         <a:solidFill>
-          <a:srgbClr val="FFFFFF"/>
+          <a:srgbClr val="1C3F60"/>
         </a:solidFill>
       </p:bgPr>
     </p:bg>
@@ -3159,8 +3110,8 @@
         </p:nvSpPr>
         <p:spPr>
           <a:xfrm>
-            <a:off x="640080" y="457200"/>
-            <a:ext cx="9144000" cy="365760"/>
+            <a:off x="640080" y="2834640"/>
+            <a:ext cx="10515600" cy="1097280"/>
           </a:xfrm>
           <a:prstGeom prst="rect">
             <a:avLst/>
@@ -3176,368 +3127,39 @@
               <a:buNone/>
             </a:pPr>
             <a:r>
-              <a:rPr lang="en-US" sz="1200" b="1" spc="200" kern="0" dirty="0">
-                <a:solidFill>
-                  <a:srgbClr val="D97E3F"/>
-                </a:solidFill>
-                <a:latin typeface="Calibri" pitchFamily="34" charset="0"/>
-                <a:ea typeface="Calibri" pitchFamily="34" charset="-122"/>
-                <a:cs typeface="Calibri" pitchFamily="34" charset="-120"/>
-              </a:rPr>
-              <a:t>LOOKING AHEAD</a:t>
-            </a:r>
-            <a:endParaRPr lang="en-US" sz="1200" dirty="0"/>
-          </a:p>
-        </p:txBody>
-      </p:sp>
-      <p:sp>
-        <p:nvSpPr>
-          <p:cNvPr id="3" name="Text 1"/>
-          <p:cNvSpPr/>
-          <p:nvPr/>
-        </p:nvSpPr>
-        <p:spPr>
-          <a:xfrm>
-            <a:off x="640080" y="777240"/>
-            <a:ext cx="10515600" cy="822960"/>
-          </a:xfrm>
-          <a:prstGeom prst="rect">
-            <a:avLst/>
-          </a:prstGeom>
-          <a:noFill/>
-          <a:ln/>
-        </p:spPr>
-        <p:txBody>
-          <a:bodyPr wrap="square" rtlCol="0" anchor="ctr"/>
-          <a:lstStyle/>
-          <a:p>
-            <a:pPr indent="0" marL="0">
-              <a:buNone/>
-            </a:pPr>
-            <a:r>
-              <a:rPr lang="en-US" sz="2700" b="1" dirty="0">
-                <a:solidFill>
-                  <a:srgbClr val="1B3A34"/>
+              <a:rPr lang="en-US" sz="3400" b="1" dirty="0">
+                <a:solidFill>
+                  <a:srgbClr val="FFFFFF"/>
                 </a:solidFill>
                 <a:latin typeface="Georgia" pitchFamily="34" charset="0"/>
                 <a:ea typeface="Georgia" pitchFamily="34" charset="-122"/>
                 <a:cs typeface="Georgia" pitchFamily="34" charset="-120"/>
               </a:rPr>
-              <a:t>Month one → Month two</a:t>
-            </a:r>
-            <a:endParaRPr lang="en-US" sz="2700" dirty="0"/>
-          </a:p>
-        </p:txBody>
-      </p:sp>
-      <p:sp>
-        <p:nvSpPr>
-          <p:cNvPr id="4" name="Shape 2"/>
-          <p:cNvSpPr/>
-          <p:nvPr/>
-        </p:nvSpPr>
-        <p:spPr>
-          <a:xfrm>
-            <a:off x="640080" y="2011680"/>
-            <a:ext cx="5212080" cy="3200400"/>
-          </a:xfrm>
-          <a:prstGeom prst="roundRect">
-            <a:avLst>
-              <a:gd name="adj" fmla="val 1714"/>
-            </a:avLst>
+              <a:t>Nice work, cycle one.</a:t>
+            </a:r>
+            <a:endParaRPr lang="en-US" sz="3400" dirty="0"/>
+          </a:p>
+        </p:txBody>
+      </p:sp>
+      <p:sp>
+        <p:nvSpPr>
+          <p:cNvPr id="3" name="Shape 1"/>
+          <p:cNvSpPr/>
+          <p:nvPr/>
+        </p:nvSpPr>
+        <p:spPr>
+          <a:xfrm>
+            <a:off x="640080" y="3931920"/>
+            <a:ext cx="1280160" cy="45720"/>
+          </a:xfrm>
+          <a:prstGeom prst="rect">
+            <a:avLst/>
           </a:prstGeom>
           <a:solidFill>
-            <a:srgbClr val="F4F1EC"/>
+            <a:srgbClr val="D97E3F"/>
           </a:solidFill>
           <a:ln/>
         </p:spPr>
-      </p:sp>
-      <p:sp>
-        <p:nvSpPr>
-          <p:cNvPr id="5" name="Text 3"/>
-          <p:cNvSpPr/>
-          <p:nvPr/>
-        </p:nvSpPr>
-        <p:spPr>
-          <a:xfrm>
-            <a:off x="960120" y="2240280"/>
-            <a:ext cx="4572000" cy="320040"/>
-          </a:xfrm>
-          <a:prstGeom prst="rect">
-            <a:avLst/>
-          </a:prstGeom>
-          <a:noFill/>
-          <a:ln/>
-        </p:spPr>
-        <p:txBody>
-          <a:bodyPr wrap="square" rtlCol="0" anchor="ctr"/>
-          <a:lstStyle/>
-          <a:p>
-            <a:pPr indent="0" marL="0">
-              <a:buNone/>
-            </a:pPr>
-            <a:r>
-              <a:rPr lang="en-US" sz="1100" b="1" spc="150" kern="0" dirty="0">
-                <a:solidFill>
-                  <a:srgbClr val="D97E3F"/>
-                </a:solidFill>
-                <a:latin typeface="Calibri" pitchFamily="34" charset="0"/>
-                <a:ea typeface="Calibri" pitchFamily="34" charset="-122"/>
-                <a:cs typeface="Calibri" pitchFamily="34" charset="-120"/>
-              </a:rPr>
-              <a:t>MONTH ONE</a:t>
-            </a:r>
-            <a:endParaRPr lang="en-US" sz="1100" dirty="0"/>
-          </a:p>
-        </p:txBody>
-      </p:sp>
-      <p:sp>
-        <p:nvSpPr>
-          <p:cNvPr id="6" name="Text 4"/>
-          <p:cNvSpPr/>
-          <p:nvPr/>
-        </p:nvSpPr>
-        <p:spPr>
-          <a:xfrm>
-            <a:off x="960120" y="2606040"/>
-            <a:ext cx="4572000" cy="1371600"/>
-          </a:xfrm>
-          <a:prstGeom prst="rect">
-            <a:avLst/>
-          </a:prstGeom>
-          <a:noFill/>
-          <a:ln/>
-        </p:spPr>
-        <p:txBody>
-          <a:bodyPr wrap="square" rtlCol="0" anchor="t"/>
-          <a:lstStyle/>
-          <a:p>
-            <a:pPr indent="0" marL="0">
-              <a:buNone/>
-            </a:pPr>
-            <a:r>
-              <a:rPr lang="en-US" sz="1500" dirty="0">
-                <a:solidFill>
-                  <a:srgbClr val="2A2A2A"/>
-                </a:solidFill>
-                <a:latin typeface="Calibri" pitchFamily="34" charset="0"/>
-                <a:ea typeface="Calibri" pitchFamily="34" charset="-122"/>
-                <a:cs typeface="Calibri" pitchFamily="34" charset="-120"/>
-              </a:rPr>
-              <a:t>Comfortable enough with tools to ask a real question and defend it.</a:t>
-            </a:r>
-            <a:endParaRPr lang="en-US" sz="1500" dirty="0"/>
-          </a:p>
-        </p:txBody>
-      </p:sp>
-      <p:sp>
-        <p:nvSpPr>
-          <p:cNvPr id="7" name="Shape 5"/>
-          <p:cNvSpPr/>
-          <p:nvPr/>
-        </p:nvSpPr>
-        <p:spPr>
-          <a:xfrm>
-            <a:off x="6172200" y="2011680"/>
-            <a:ext cx="5349240" cy="3200400"/>
-          </a:xfrm>
-          <a:prstGeom prst="roundRect">
-            <a:avLst>
-              <a:gd name="adj" fmla="val 1714"/>
-            </a:avLst>
-          </a:prstGeom>
-          <a:solidFill>
-            <a:srgbClr val="1B3A34"/>
-          </a:solidFill>
-          <a:ln/>
-        </p:spPr>
-      </p:sp>
-      <p:sp>
-        <p:nvSpPr>
-          <p:cNvPr id="8" name="Text 6"/>
-          <p:cNvSpPr/>
-          <p:nvPr/>
-        </p:nvSpPr>
-        <p:spPr>
-          <a:xfrm>
-            <a:off x="6492240" y="2240280"/>
-            <a:ext cx="4754880" cy="320040"/>
-          </a:xfrm>
-          <a:prstGeom prst="rect">
-            <a:avLst/>
-          </a:prstGeom>
-          <a:noFill/>
-          <a:ln/>
-        </p:spPr>
-        <p:txBody>
-          <a:bodyPr wrap="square" rtlCol="0" anchor="ctr"/>
-          <a:lstStyle/>
-          <a:p>
-            <a:pPr indent="0" marL="0">
-              <a:buNone/>
-            </a:pPr>
-            <a:r>
-              <a:rPr lang="en-US" sz="1100" b="1" spc="150" kern="0" dirty="0">
-                <a:solidFill>
-                  <a:srgbClr val="D97E3F"/>
-                </a:solidFill>
-                <a:latin typeface="Calibri" pitchFamily="34" charset="0"/>
-                <a:ea typeface="Calibri" pitchFamily="34" charset="-122"/>
-                <a:cs typeface="Calibri" pitchFamily="34" charset="-120"/>
-              </a:rPr>
-              <a:t>MONTH TWO</a:t>
-            </a:r>
-            <a:endParaRPr lang="en-US" sz="1100" dirty="0"/>
-          </a:p>
-        </p:txBody>
-      </p:sp>
-      <p:sp>
-        <p:nvSpPr>
-          <p:cNvPr id="9" name="Text 7"/>
-          <p:cNvSpPr/>
-          <p:nvPr/>
-        </p:nvSpPr>
-        <p:spPr>
-          <a:xfrm>
-            <a:off x="6492240" y="2606040"/>
-            <a:ext cx="4754880" cy="1554480"/>
-          </a:xfrm>
-          <a:prstGeom prst="rect">
-            <a:avLst/>
-          </a:prstGeom>
-          <a:noFill/>
-          <a:ln/>
-        </p:spPr>
-        <p:txBody>
-          <a:bodyPr wrap="square" rtlCol="0" anchor="t"/>
-          <a:lstStyle/>
-          <a:p>
-            <a:pPr indent="0" marL="0">
-              <a:buNone/>
-            </a:pPr>
-            <a:r>
-              <a:rPr lang="en-US" sz="1500" dirty="0">
-                <a:solidFill>
-                  <a:srgbClr val="FFFFFF"/>
-                </a:solidFill>
-                <a:latin typeface="Calibri" pitchFamily="34" charset="0"/>
-                <a:ea typeface="Calibri" pitchFamily="34" charset="-122"/>
-                <a:cs typeface="Calibri" pitchFamily="34" charset="-120"/>
-              </a:rPr>
-              <a:t>SQL — same instinct, a different way into the data. The single most-requested skill in analyst postings.</a:t>
-            </a:r>
-            <a:endParaRPr lang="en-US" sz="1500" dirty="0"/>
-          </a:p>
-        </p:txBody>
-      </p:sp>
-    </p:spTree>
-  </p:cSld>
-  <p:clrMapOvr>
-    <a:masterClrMapping/>
-  </p:clrMapOvr>
-</p:sld>
-</file>
-
-<file path=ppt/slides/slide7.xml><?xml version="1.0" encoding="utf-8"?>
-<p:sld xmlns:a="http://schemas.openxmlformats.org/drawingml/2006/main" xmlns:r="http://schemas.openxmlformats.org/officeDocument/2006/relationships" xmlns:p="http://schemas.openxmlformats.org/presentationml/2006/main">
-  <p:cSld name="Slide 7">
-    <p:bg>
-      <p:bgPr>
-        <a:solidFill>
-          <a:srgbClr val="1B3A34"/>
-        </a:solidFill>
-      </p:bgPr>
-    </p:bg>
-    <p:spTree>
-      <p:nvGrpSpPr>
-        <p:cNvPr id="1" name=""/>
-        <p:cNvGrpSpPr/>
-        <p:nvPr/>
-      </p:nvGrpSpPr>
-      <p:grpSpPr>
-        <a:xfrm>
-          <a:off x="0" y="0"/>
-          <a:ext cx="0" cy="0"/>
-          <a:chOff x="0" y="0"/>
-          <a:chExt cx="0" cy="0"/>
-        </a:xfrm>
-      </p:grpSpPr>
-      <p:sp>
-        <p:nvSpPr>
-          <p:cNvPr id="2" name="Text 0"/>
-          <p:cNvSpPr/>
-          <p:nvPr/>
-        </p:nvSpPr>
-        <p:spPr>
-          <a:xfrm>
-            <a:off x="640080" y="2743200"/>
-            <a:ext cx="10515600" cy="1097280"/>
-          </a:xfrm>
-          <a:prstGeom prst="rect">
-            <a:avLst/>
-          </a:prstGeom>
-          <a:noFill/>
-          <a:ln/>
-        </p:spPr>
-        <p:txBody>
-          <a:bodyPr wrap="square" rtlCol="0" anchor="ctr"/>
-          <a:lstStyle/>
-          <a:p>
-            <a:pPr indent="0" marL="0">
-              <a:buNone/>
-            </a:pPr>
-            <a:r>
-              <a:rPr lang="en-US" sz="3600" b="1" dirty="0">
-                <a:solidFill>
-                  <a:srgbClr val="FFFFFF"/>
-                </a:solidFill>
-                <a:latin typeface="Georgia" pitchFamily="34" charset="0"/>
-                <a:ea typeface="Georgia" pitchFamily="34" charset="-122"/>
-                <a:cs typeface="Georgia" pitchFamily="34" charset="-120"/>
-              </a:rPr>
-              <a:t>Nice work, cycle one.</a:t>
-            </a:r>
-            <a:endParaRPr lang="en-US" sz="3600" dirty="0"/>
-          </a:p>
-        </p:txBody>
-      </p:sp>
-      <p:sp>
-        <p:nvSpPr>
-          <p:cNvPr id="3" name="Text 1"/>
-          <p:cNvSpPr/>
-          <p:nvPr/>
-        </p:nvSpPr>
-        <p:spPr>
-          <a:xfrm>
-            <a:off x="640080" y="6035040"/>
-            <a:ext cx="7315200" cy="365760"/>
-          </a:xfrm>
-          <a:prstGeom prst="rect">
-            <a:avLst/>
-          </a:prstGeom>
-          <a:noFill/>
-          <a:ln/>
-        </p:spPr>
-        <p:txBody>
-          <a:bodyPr wrap="square" rtlCol="0" anchor="ctr"/>
-          <a:lstStyle/>
-          <a:p>
-            <a:pPr indent="0" marL="0">
-              <a:buNone/>
-            </a:pPr>
-            <a:r>
-              <a:rPr lang="en-US" sz="1100" b="1" spc="200" kern="0" dirty="0">
-                <a:solidFill>
-                  <a:srgbClr val="D97E3F"/>
-                </a:solidFill>
-                <a:latin typeface="Calibri" pitchFamily="34" charset="0"/>
-                <a:ea typeface="Calibri" pitchFamily="34" charset="-122"/>
-                <a:cs typeface="Calibri" pitchFamily="34" charset="-120"/>
-              </a:rPr>
-              <a:t>DSDG DATA ANALYTICS</a:t>
-            </a:r>
-            <a:endParaRPr lang="en-US" sz="1100" dirty="0"/>
-          </a:p>
-        </p:txBody>
       </p:sp>
     </p:spTree>
   </p:cSld>

</xml_diff>